<commit_message>
Fix PbP.BDB 2018-playoffs mischaracterization in UG Module 4
Module 4 (Shot Charts and Spatial Data) described PbP.BDB as the real
2018 NBA playoffs. It is Golden State's real, complete 2017-18 NBA
regular-season play-by-play log (82 games). Houston and Cleveland
never played each other in this dataset; each appears only in its own
real 2017-18 regular-season games against Golden State. Corrected all
student notes, lab, quiz, practice questions, session plan,
references, coding exercise, and the lecture slide deck (19 slides),
including the Harden-vs-Cleveland and LeBron-vs-Houston attribution
errors, which were factually impossible under this dataset's
hub-and-spoke structure.
</commit_message>
<xml_diff>
--- a/Sports-Analytics-Undergraduate/04_Shot_Charts_and_Spatial_Data/Lecture_Slides/Module04_Shot_Charts_and_Spatial_Data.pptx
+++ b/Sports-Analytics-Undergraduate/04_Shot_Charts_and_Spatial_Data/Lecture_Slides/Module04_Shot_Charts_and_Spatial_Data.pptx
@@ -2398,7 +2398,7 @@
           <a:p>
             <a:r>
               <a:rPr lang="en-US" dirty="0"/>
-              <a:t>Discussion: this is a real, measurable 16-point gap between two 2018 playoff teams. Ask: does this prove Houston's approach is 'correct'? Push toward: it shows the strategy is real and measurable, not that it guarantees winning -- Cleveland reached the Finals that same year.</a:t>
+              <a:t>Discussion: this is a real, measurable 16-point gap between Houston's and Cleveland's real shot profiles against Golden State. Ask: does this prove Houston's approach is 'correct'? Push toward: it shows the strategy is real and measurable, not that it guarantees winning -- Cleveland reached the 2018 Finals that same year.</a:t>
             </a:r>
             <a:endParaRPr lang="en-US" dirty="0"/>
           </a:p>
@@ -5947,7 +5947,7 @@
                 <a:ea typeface="Cambria" pitchFamily="34" charset="-122"/>
                 <a:cs typeface="Cambria" pitchFamily="34" charset="-120"/>
               </a:rPr>
-              <a:t>Houston Rockets: 273 Real 2018 Playoff Attempts</a:t>
+              <a:t>Houston Rockets: 273 Real Attempts vs. Golden State</a:t>
             </a:r>
             <a:endParaRPr lang="en-US" sz="2600" dirty="0"/>
           </a:p>
@@ -6010,7 +6010,7 @@
                 <a:ea typeface="Calibri" pitchFamily="34" charset="-122"/>
                 <a:cs typeface="Calibri" pitchFamily="34" charset="-120"/>
               </a:rPr>
-              <a:t>shotchart(hou, x="xc", y="yc", z="result2", scatter=TRUE). Data: PbP.BDB, 2018 NBA playoffs.</a:t>
+              <a:t>shotchart(hou, x="xc", y="yc", z="result2", scatter=TRUE). Data: PbP.BDB, Houston's three real 2017-18 regular-season games vs. Golden State.</a:t>
             </a:r>
             <a:endParaRPr lang="en-US" sz="1000" dirty="0"/>
           </a:p>
@@ -6575,7 +6575,7 @@
                 <a:ea typeface="Calibri" pitchFamily="34" charset="-122"/>
                 <a:cs typeface="Calibri" pitchFamily="34" charset="-120"/>
               </a:rPr>
-              <a:t>shotchart(hou, x="xc", y="yc", type="density-hexbin", nbins=24). Data: PbP.BDB, 2018 NBA playoffs.</a:t>
+              <a:t>shotchart(hou, x="xc", y="yc", type="density-hexbin", nbins=24). Data: PbP.BDB, Houston's three real 2017-18 regular-season games vs. Golden State.</a:t>
             </a:r>
             <a:endParaRPr lang="en-US" sz="1000" dirty="0"/>
           </a:p>
@@ -6788,7 +6788,7 @@
                 <a:ea typeface="Calibri" pitchFamily="34" charset="-122"/>
                 <a:cs typeface="Calibri" pitchFamily="34" charset="-120"/>
               </a:rPr>
-              <a:t>Why raw coordinates need a half-court transform, and built a real shot chart and density map from Houston's 273 real 2018 playoff attempts.</a:t>
+              <a:t>Why raw coordinates need a half-court transform, and built a real shot chart and density map from Houston's 273 real attempts in their three 2017-18 regular-season games against Golden State.</a:t>
             </a:r>
             <a:endParaRPr lang="en-US" sz="1400" dirty="0"/>
           </a:p>
@@ -8413,7 +8413,7 @@
                 <a:ea typeface="Cambria" pitchFamily="34" charset="-122"/>
                 <a:cs typeface="Cambria" pitchFamily="34" charset="-120"/>
               </a:rPr>
-              <a:t>All 14,354 Real 2018 Playoff Attempts, by Zone</a:t>
+              <a:t>All 14,354 Real Attempts in This Dataset, by Zone</a:t>
             </a:r>
             <a:endParaRPr lang="en-US" sz="2500" dirty="0"/>
           </a:p>
@@ -9377,7 +9377,7 @@
                 <a:ea typeface="Calibri" pitchFamily="34" charset="-122"/>
                 <a:cs typeface="Calibri" pitchFamily="34" charset="-120"/>
               </a:rPr>
-              <a:t>The long two is the smallest share of any zone leaguewide -- only 14.8% of every real attempt.</a:t>
+              <a:t>The long two is the smallest share of any zone in this dataset -- only 14.8% of every real attempt.</a:t>
             </a:r>
             <a:endParaRPr lang="en-US" sz="1500" dirty="0"/>
           </a:p>
@@ -9416,7 +9416,7 @@
                 <a:ea typeface="Calibri" pitchFamily="34" charset="-122"/>
                 <a:cs typeface="Calibri" pitchFamily="34" charset="-120"/>
               </a:rPr>
-              <a:t>Data: PbP.BDB, 2018 NBA playoffs, all 30 teams, computed in module4_shot_charts.R.</a:t>
+              <a:t>Data: PbP.BDB, Golden State's real 2017-18 regular season, computed in module4_shot_charts.R.</a:t>
             </a:r>
             <a:endParaRPr lang="en-US" sz="1000" dirty="0"/>
           </a:p>
@@ -9629,7 +9629,7 @@
                 <a:ea typeface="Calibri" pitchFamily="34" charset="-122"/>
                 <a:cs typeface="Calibri" pitchFamily="34" charset="-120"/>
               </a:rPr>
-              <a:t>of all real 2018 playoff</a:t>
+              <a:t>of all real attempts in</a:t>
             </a:r>
             <a:endParaRPr lang="en-US" sz="1300" dirty="0"/>
           </a:p>
@@ -9649,7 +9649,7 @@
                 <a:ea typeface="Calibri" pitchFamily="34" charset="-122"/>
                 <a:cs typeface="Calibri" pitchFamily="34" charset="-120"/>
               </a:rPr>
-              <a:t>attempts came from the</a:t>
+              <a:t>this dataset came from the</a:t>
             </a:r>
             <a:endParaRPr lang="en-US" sz="1300" dirty="0"/>
           </a:p>
@@ -10934,7 +10934,7 @@
                 <a:ea typeface="Calibri" pitchFamily="34" charset="-122"/>
                 <a:cs typeface="Calibri" pitchFamily="34" charset="-120"/>
               </a:rPr>
-              <a:t>Points per shot computed from the leaguewide zone table, PbP.BDB, 2018 NBA playoffs.</a:t>
+              <a:t>Points per shot computed from the zone table, PbP.BDB, Golden State's real 2017-18 regular season.</a:t>
             </a:r>
             <a:endParaRPr lang="en-US" sz="1000" dirty="0"/>
           </a:p>
@@ -11203,7 +11203,7 @@
                 <a:ea typeface="Calibri" pitchFamily="34" charset="-122"/>
                 <a:cs typeface="Calibri" pitchFamily="34" charset="-120"/>
               </a:rPr>
-              <a:t>Real footage from the same 2018 postseason our data comes from. Watch for how many of Golden State's shots come from the rim or from three.</a:t>
+              <a:t>Real footage from the same Golden State roster this module's real regular-season data comes from. Watch for how many of Golden State's shots come from the rim or from three.</a:t>
             </a:r>
             <a:endParaRPr lang="en-US" sz="1300" dirty="0"/>
           </a:p>
@@ -11636,7 +11636,7 @@
                 <a:ea typeface="Cambria" pitchFamily="34" charset="-122"/>
                 <a:cs typeface="Cambria" pitchFamily="34" charset="-120"/>
               </a:rPr>
-              <a:t>Two Real 2018 Playoff Teams, Zone by Zone</a:t>
+              <a:t>Two Real Teams, Zone by Zone</a:t>
             </a:r>
             <a:endParaRPr lang="en-US" sz="2600" dirty="0"/>
           </a:p>
@@ -12818,7 +12818,7 @@
                 <a:ea typeface="Calibri" pitchFamily="34" charset="-122"/>
                 <a:cs typeface="Calibri" pitchFamily="34" charset="-120"/>
               </a:rPr>
-              <a:t>Data: PbP.BDB, 2018 NBA playoffs. Houston Rockets (273 real attempts) vs. Cleveland Cavaliers.</a:t>
+              <a:t>Data: PbP.BDB, Golden State's real 2017-18 regular season. Houston Rockets (273 real attempts) vs. Cleveland Cavaliers (each team's own real games against Golden State).</a:t>
             </a:r>
             <a:endParaRPr lang="en-US" sz="1000" dirty="0"/>
           </a:p>
@@ -13213,7 +13213,7 @@
                 <a:ea typeface="Calibri" pitchFamily="34" charset="-122"/>
                 <a:cs typeface="Calibri" pitchFamily="34" charset="-120"/>
               </a:rPr>
-              <a:t>Rim share + three share, each team, PbP.BDB 2018 playoffs.</a:t>
+              <a:t>Rim share + three share, each team, PbP.BDB, Golden State's real 2017-18 regular season.</a:t>
             </a:r>
             <a:endParaRPr lang="en-US" sz="1000" dirty="0"/>
           </a:p>
@@ -13602,7 +13602,7 @@
                 <a:ea typeface="Calibri" pitchFamily="34" charset="-122"/>
                 <a:cs typeface="Calibri" pitchFamily="34" charset="-120"/>
               </a:rPr>
-              <a:t>shotchart(cle, x="xc", y="yc", z="result2", scatter=TRUE). Data: PbP.BDB, 2018 NBA playoffs.</a:t>
+              <a:t>shotchart(cle, x="xc", y="yc", z="result2", scatter=TRUE). Data: PbP.BDB, Cleveland's two real 2017-18 regular-season games vs. Golden State.</a:t>
             </a:r>
             <a:endParaRPr lang="en-US" sz="1000" dirty="0"/>
           </a:p>
@@ -13776,7 +13776,7 @@
                 <a:ea typeface="Calibri" pitchFamily="34" charset="-122"/>
                 <a:cs typeface="Calibri" pitchFamily="34" charset="-120"/>
               </a:rPr>
-              <a:t>Get into groups of 3-4. I'll assign your group one more real 2018 playoff team.</a:t>
+              <a:t>Get into groups of 3-4. I'll assign your group one more real team Golden State played that season.</a:t>
             </a:r>
             <a:endParaRPr lang="en-US" sz="1500" dirty="0"/>
           </a:p>
@@ -14682,7 +14682,7 @@
                 <a:ea typeface="Cambria" pitchFamily="34" charset="-122"/>
                 <a:cs typeface="Cambria" pitchFamily="34" charset="-120"/>
               </a:rPr>
-              <a:t>James Harden: 39 Real Attempts vs. Cleveland</a:t>
+              <a:t>James Harden: 39 Real Attempts vs. Golden State</a:t>
             </a:r>
             <a:endParaRPr lang="en-US" sz="2600" dirty="0"/>
           </a:p>
@@ -14745,7 +14745,7 @@
                 <a:ea typeface="Calibri" pitchFamily="34" charset="-122"/>
                 <a:cs typeface="Calibri" pitchFamily="34" charset="-120"/>
               </a:rPr>
-              <a:t>Data: PbP.BDB, 2018 NBA playoffs, Houston vs. Cleveland.</a:t>
+              <a:t>Data: PbP.BDB, Houston's real 2017-18 regular-season games vs. Golden State.</a:t>
             </a:r>
             <a:endParaRPr lang="en-US" sz="1000" dirty="0"/>
           </a:p>
@@ -15708,7 +15708,7 @@
                 <a:ea typeface="Cambria" pitchFamily="34" charset="-122"/>
                 <a:cs typeface="Cambria" pitchFamily="34" charset="-120"/>
               </a:rPr>
-              <a:t>LeBron James: 36 Real Attempts vs. Houston</a:t>
+              <a:t>LeBron James: 36 Real Attempts vs. Golden State</a:t>
             </a:r>
             <a:endParaRPr lang="en-US" sz="2600" dirty="0"/>
           </a:p>
@@ -15771,7 +15771,7 @@
                 <a:ea typeface="Calibri" pitchFamily="34" charset="-122"/>
                 <a:cs typeface="Calibri" pitchFamily="34" charset="-120"/>
               </a:rPr>
-              <a:t>Data: PbP.BDB, 2018 NBA playoffs, Cleveland vs. Houston.</a:t>
+              <a:t>Data: PbP.BDB, Cleveland's real 2017-18 regular-season games vs. Golden State.</a:t>
             </a:r>
             <a:endParaRPr lang="en-US" sz="1000" dirty="0"/>
           </a:p>
@@ -17018,7 +17018,7 @@
                 <a:ea typeface="Calibri" pitchFamily="34" charset="-122"/>
                 <a:cs typeface="Calibri" pitchFamily="34" charset="-120"/>
               </a:rPr>
-              <a:t>Distance zones, real 2018 playoff data, and the Moreyball question</a:t>
+              <a:t>Distance zones, Golden State's real regular-season data, and the Moreyball question</a:t>
             </a:r>
             <a:endParaRPr lang="en-US" sz="1200" dirty="0"/>
           </a:p>
@@ -17412,7 +17412,7 @@
                 <a:ea typeface="Cambria" pitchFamily="34" charset="-122"/>
                 <a:cs typeface="Cambria" pitchFamily="34" charset="-120"/>
               </a:rPr>
-              <a:t>87.5% at the Rim, in Real Playoff Minutes</a:t>
+              <a:t>87.5% at the Rim, in a Real Small Sample</a:t>
             </a:r>
             <a:endParaRPr lang="en-US" sz="2700" dirty="0"/>
           </a:p>
@@ -17614,7 +17614,7 @@
                 <a:ea typeface="Calibri" pitchFamily="34" charset="-122"/>
                 <a:cs typeface="Calibri" pitchFamily="34" charset="-120"/>
               </a:rPr>
-              <a:t>the leaguewide rim average across the entire 2018 playoffs was 64.4%. LeBron's real sample here is well above that.
+              <a:t>the rim average across this module's full real sample (Golden State's 2017-18 regular season) was 64.4%. LeBron's real sample here is well above that.
 </a:t>
             </a:r>
             <a:pPr indent="0" marL="0">
@@ -19266,7 +19266,7 @@
                 <a:ea typeface="Calibri" pitchFamily="34" charset="-122"/>
                 <a:cs typeface="Calibri" pitchFamily="34" charset="-120"/>
               </a:rPr>
-              <a:t>Points per shot (0.83 for the long two vs. 1.13 for three, in real 2018 playoff data) can rank two zones in the opposite order that field goal percentage alone would suggest.</a:t>
+              <a:t>Points per shot (0.83 for the long two vs. 1.13 for three, in this module's real 2017-18 regular-season data) can rank two zones in the opposite order that field goal percentage alone would suggest.</a:t>
             </a:r>
             <a:endParaRPr lang="en-US" sz="1500" dirty="0"/>
           </a:p>
@@ -19390,7 +19390,7 @@
                 <a:ea typeface="Calibri" pitchFamily="34" charset="-122"/>
                 <a:cs typeface="Calibri" pitchFamily="34" charset="-120"/>
               </a:rPr>
-              <a:t>Every number in this module came from PbP.BDB, real 2018 NBA playoff play-by-play data, reproducible by anyone who runs the script.</a:t>
+              <a:t>Every number in this module came from PbP.BDB, Golden State's real, complete 2017-18 NBA regular-season play-by-play log, reproducible by anyone who runs the script.</a:t>
             </a:r>
             <a:endParaRPr lang="en-US" sz="1500" dirty="0"/>
           </a:p>
@@ -19887,7 +19887,7 @@
                 <a:ea typeface="Calibri" pitchFamily="34" charset="-122"/>
                 <a:cs typeface="Calibri" pitchFamily="34" charset="-120"/>
               </a:rPr>
-              <a:t>Zuccolotto, Manisera &amp; Sandri. BasketballAnalyzeR (R package), shotchart() function and the PbP.BDB dataset (2017-18 NBA playoffs). CRAN.</a:t>
+              <a:t>Zuccolotto, Manisera &amp; Sandri. BasketballAnalyzeR (R package), shotchart() function and the PbP.BDB dataset (Golden State Warriors' real, complete 2017-18 NBA regular season). CRAN.</a:t>
             </a:r>
             <a:endParaRPr lang="en-US" sz="1400" dirty="0"/>
           </a:p>
@@ -20430,7 +20430,7 @@
                 <a:ea typeface="Calibri" pitchFamily="34" charset="-122"/>
                 <a:cs typeface="Calibri" pitchFamily="34" charset="-120"/>
               </a:rPr>
-              <a:t>Build a real shot chart from real 2018 playoff data using BasketballAnalyzeR's shotchart() function.</a:t>
+              <a:t>Build a real shot chart from Golden State's real 2017-18 regular-season data using BasketballAnalyzeR's shotchart() function.</a:t>
             </a:r>
             <a:endParaRPr lang="en-US" sz="1600" dirty="0"/>
           </a:p>
@@ -21016,7 +21016,7 @@
                 <a:ea typeface="Calibri" pitchFamily="34" charset="-122"/>
                 <a:cs typeface="Calibri" pitchFamily="34" charset="-120"/>
               </a:rPr>
-              <a:t>Every chart in this module comes from BasketballAnalyzeR's PbP.BDB dataset: real, event-level play-by-play data from the entire 2018 NBA playoffs. 82 real games. 14,354 real field goal attempts. Every shot's exact x-y coordinates, recorded as it happened.</a:t>
+              <a:t>Every chart in this module comes from BasketballAnalyzeR's PbP.BDB dataset: the same real, event-level play-by-play data Module 3 uses, Golden State's real, complete 2017-18 regular season. 82 real games. 14,354 real field goal attempts. Every shot's exact x-y coordinates, recorded as it happened.</a:t>
             </a:r>
             <a:endParaRPr lang="en-US" sz="1700" dirty="0"/>
           </a:p>
@@ -21055,7 +21055,7 @@
                 <a:ea typeface="Calibri" pitchFamily="34" charset="-122"/>
                 <a:cs typeface="Calibri" pitchFamily="34" charset="-120"/>
               </a:rPr>
-              <a:t>This is playoff data, not a full regular season -- a real, honest fact about the sample we'll return to later in this module.</a:t>
+              <a:t>This is one team's real, complete regular season, not a leaguewide sample -- every other team's rows here are limited to its own few real regular-season games against Golden State, a real, honest fact about the sample we'll return to later in this module.</a:t>
             </a:r>
             <a:endParaRPr lang="en-US" sz="1400" dirty="0"/>
           </a:p>

</xml_diff>